<commit_message>
fear(finetune vs rag): Token Consumption Analysis
</commit_message>
<xml_diff>
--- a/presentation.pptx
+++ b/presentation.pptx
@@ -12186,82 +12186,30 @@
           </a:p>
         </p:txBody>
       </p:sp>
-      <p:sp>
-        <p:nvSpPr>
-          <p:cNvPr id="3" name="TextBox 2"/>
-          <p:cNvSpPr txBox="1"/>
+      <p:pic>
+        <p:nvPicPr>
+          <p:cNvPr id="3" name="Picture 2" descr="decision_framework.png"/>
+          <p:cNvPicPr>
+            <a:picLocks noChangeAspect="1"/>
+          </p:cNvPicPr>
           <p:nvPr/>
-        </p:nvSpPr>
+        </p:nvPicPr>
+        <p:blipFill>
+          <a:blip r:embed="rId2"/>
+          <a:stretch>
+            <a:fillRect/>
+          </a:stretch>
+        </p:blipFill>
         <p:spPr>
           <a:xfrm>
-            <a:off x="457200" y="1188720"/>
-            <a:ext cx="10972800" cy="3200400"/>
+            <a:off x="1371600" y="1097280"/>
+            <a:ext cx="9144000" cy="3200400"/>
           </a:xfrm>
           <a:prstGeom prst="rect">
             <a:avLst/>
           </a:prstGeom>
-          <a:noFill/>
         </p:spPr>
-        <p:txBody>
-          <a:bodyPr wrap="square">
-            <a:spAutoFit/>
-          </a:bodyPr>
-          <a:lstStyle/>
-          <a:p>
-            <a:pPr algn="l">
-              <a:defRPr sz="1300" b="0">
-                <a:solidFill>
-                  <a:srgbClr val="1C2A3A"/>
-                </a:solidFill>
-                <a:latin typeface="Consolas"/>
-              </a:defRPr>
-            </a:pPr>
-            <a:r>
-              <a:t>              Does the task require NEW REASONING SKILLS?</a:t>
-            </a:r>
-            <a:br/>
-            <a:r>
-              <a:t>             /                                           \</a:t>
-            </a:r>
-            <a:br/>
-            <a:r>
-              <a:t>           YES                                           NO</a:t>
-            </a:r>
-            <a:br/>
-            <a:r>
-              <a:t>            |                                             |</a:t>
-            </a:r>
-            <a:br/>
-            <a:r>
-              <a:t>   Does it need                                Does it need</a:t>
-            </a:r>
-            <a:br/>
-            <a:r>
-              <a:t>  FRESH/DYNAMIC data?                        FRESH/DYNAMIC data?</a:t>
-            </a:r>
-            <a:br/>
-            <a:r>
-              <a:t>    /          \                               /          \</a:t>
-            </a:r>
-            <a:br/>
-            <a:r>
-              <a:t>  YES           NO                           YES           NO</a:t>
-            </a:r>
-            <a:br/>
-            <a:r>
-              <a:t>   |             |                            |             |</a:t>
-            </a:r>
-            <a:br/>
-            <a:r>
-              <a:t> HYBRID      FINE-TUNE                       RAG        PROMPT ENG.</a:t>
-            </a:r>
-            <a:br/>
-            <a:r>
-              <a:t>(FT+RAG)    (Best accuracy)               (Dynamic)    (Quick start)</a:t>
-            </a:r>
-          </a:p>
-        </p:txBody>
-      </p:sp>
+      </p:pic>
       <p:sp>
         <p:nvSpPr>
           <p:cNvPr id="4" name="Rectangle 3"/>
@@ -18975,94 +18923,30 @@
           </a:p>
         </p:txBody>
       </p:sp>
-      <p:sp>
-        <p:nvSpPr>
-          <p:cNvPr id="3" name="TextBox 2"/>
-          <p:cNvSpPr txBox="1"/>
+      <p:pic>
+        <p:nvPicPr>
+          <p:cNvPr id="3" name="Picture 2" descr="hybrid_architecture.png"/>
+          <p:cNvPicPr>
+            <a:picLocks noChangeAspect="1"/>
+          </p:cNvPicPr>
           <p:nvPr/>
-        </p:nvSpPr>
+        </p:nvPicPr>
+        <p:blipFill>
+          <a:blip r:embed="rId2"/>
+          <a:stretch>
+            <a:fillRect/>
+          </a:stretch>
+        </p:blipFill>
         <p:spPr>
           <a:xfrm>
-            <a:off x="914400" y="1371600"/>
-            <a:ext cx="4572000" cy="3657600"/>
+            <a:off x="457200" y="1188720"/>
+            <a:ext cx="5943600" cy="4114800"/>
           </a:xfrm>
           <a:prstGeom prst="rect">
             <a:avLst/>
           </a:prstGeom>
-          <a:noFill/>
         </p:spPr>
-        <p:txBody>
-          <a:bodyPr wrap="square">
-            <a:spAutoFit/>
-          </a:bodyPr>
-          <a:lstStyle/>
-          <a:p>
-            <a:pPr algn="l">
-              <a:defRPr sz="1400" b="0">
-                <a:solidFill>
-                  <a:srgbClr val="1C2A3A"/>
-                </a:solidFill>
-                <a:latin typeface="Consolas"/>
-              </a:defRPr>
-            </a:pPr>
-            <a:r>
-              <a:t>  User Question + Financial Table</a:t>
-            </a:r>
-            <a:br/>
-            <a:r>
-              <a:t>         |</a:t>
-            </a:r>
-            <a:br/>
-            <a:r>
-              <a:t>    +----+----+</a:t>
-            </a:r>
-            <a:br/>
-            <a:r>
-              <a:t>    |         |</a:t>
-            </a:r>
-            <a:br/>
-            <a:r>
-              <a:t> [RETRIEVE]  [FINE-TUNED MODEL]</a:t>
-            </a:r>
-            <a:br/>
-            <a:r>
-              <a:t>  from DB     processes table</a:t>
-            </a:r>
-            <a:br/>
-            <a:r>
-              <a:t>    |         |</a:t>
-            </a:r>
-            <a:br/>
-            <a:r>
-              <a:t>    +----+----+</a:t>
-            </a:r>
-            <a:br/>
-            <a:r>
-              <a:t>         |</a:t>
-            </a:r>
-            <a:br/>
-            <a:r>
-              <a:t>  [FINE-TUNED MODEL</a:t>
-            </a:r>
-            <a:br/>
-            <a:r>
-              <a:t>   + Retrieved Context]</a:t>
-            </a:r>
-            <a:br/>
-            <a:r>
-              <a:t>         |</a:t>
-            </a:r>
-            <a:br/>
-            <a:r>
-              <a:t>  Answer with domain reasoning</a:t>
-            </a:r>
-            <a:br/>
-            <a:r>
-              <a:t>  + fresh context + citations</a:t>
-            </a:r>
-          </a:p>
-        </p:txBody>
-      </p:sp>
+      </p:pic>
       <p:sp>
         <p:nvSpPr>
           <p:cNvPr id="4" name="Rectangle 3"/>
@@ -19071,8 +18955,8 @@
         </p:nvSpPr>
         <p:spPr>
           <a:xfrm>
-            <a:off x="6400800" y="1371600"/>
-            <a:ext cx="5029200" cy="1645920"/>
+            <a:off x="6858000" y="1371600"/>
+            <a:ext cx="4846320" cy="1645920"/>
           </a:xfrm>
           <a:prstGeom prst="rect">
             <a:avLst/>
@@ -19149,8 +19033,8 @@
         </p:nvSpPr>
         <p:spPr>
           <a:xfrm>
-            <a:off x="6400800" y="3291840"/>
-            <a:ext cx="5029200" cy="1645920"/>
+            <a:off x="6858000" y="3291840"/>
+            <a:ext cx="4846320" cy="1645920"/>
           </a:xfrm>
           <a:prstGeom prst="rect">
             <a:avLst/>
@@ -40671,82 +40555,30 @@
           </a:p>
         </p:txBody>
       </p:sp>
-      <p:sp>
-        <p:nvSpPr>
-          <p:cNvPr id="3" name="TextBox 2"/>
-          <p:cNvSpPr txBox="1"/>
+      <p:pic>
+        <p:nvPicPr>
+          <p:cNvPr id="3" name="Picture 2" descr="rag_flow.png"/>
+          <p:cNvPicPr>
+            <a:picLocks noChangeAspect="1"/>
+          </p:cNvPicPr>
           <p:nvPr/>
-        </p:nvSpPr>
+        </p:nvPicPr>
+        <p:blipFill>
+          <a:blip r:embed="rId2"/>
+          <a:stretch>
+            <a:fillRect/>
+          </a:stretch>
+        </p:blipFill>
         <p:spPr>
           <a:xfrm>
-            <a:off x="731520" y="1371600"/>
-            <a:ext cx="5486400" cy="3657600"/>
+            <a:off x="457200" y="1188720"/>
+            <a:ext cx="5943600" cy="4389120"/>
           </a:xfrm>
           <a:prstGeom prst="rect">
             <a:avLst/>
           </a:prstGeom>
-          <a:noFill/>
         </p:spPr>
-        <p:txBody>
-          <a:bodyPr wrap="square">
-            <a:spAutoFit/>
-          </a:bodyPr>
-          <a:lstStyle/>
-          <a:p>
-            <a:pPr algn="l">
-              <a:defRPr sz="1400" b="0">
-                <a:solidFill>
-                  <a:srgbClr val="1C2A3A"/>
-                </a:solidFill>
-                <a:latin typeface="Consolas"/>
-              </a:defRPr>
-            </a:pPr>
-            <a:r>
-              <a:t>User Question</a:t>
-            </a:r>
-            <a:br/>
-            <a:r>
-              <a:t>     |</a:t>
-            </a:r>
-            <a:br/>
-            <a:r>
-              <a:t>  [1. EMBED]       Convert question to vector</a:t>
-            </a:r>
-            <a:br/>
-            <a:r>
-              <a:t>     |</a:t>
-            </a:r>
-            <a:br/>
-            <a:r>
-              <a:t>  [2. RETRIEVE]    Search vector DB for similar docs</a:t>
-            </a:r>
-            <a:br/>
-            <a:r>
-              <a:t>     |</a:t>
-            </a:r>
-            <a:br/>
-            <a:r>
-              <a:t>  [3. AUGMENT]     Add retrieved docs to prompt</a:t>
-            </a:r>
-            <a:br/>
-            <a:r>
-              <a:t>     |</a:t>
-            </a:r>
-            <a:br/>
-            <a:r>
-              <a:t>  [4. GENERATE]    LLM generates answer with context</a:t>
-            </a:r>
-            <a:br/>
-            <a:r>
-              <a:t>     |</a:t>
-            </a:r>
-            <a:br/>
-            <a:r>
-              <a:t>  Answer (with source references)</a:t>
-            </a:r>
-          </a:p>
-        </p:txBody>
-      </p:sp>
+      </p:pic>
       <p:sp>
         <p:nvSpPr>
           <p:cNvPr id="4" name="Rectangle 3"/>
@@ -42017,82 +41849,30 @@
           </a:p>
         </p:txBody>
       </p:sp>
-      <p:sp>
-        <p:nvSpPr>
-          <p:cNvPr id="3" name="TextBox 2"/>
-          <p:cNvSpPr txBox="1"/>
+      <p:pic>
+        <p:nvPicPr>
+          <p:cNvPr id="3" name="Picture 2" descr="finetuning_flow.png"/>
+          <p:cNvPicPr>
+            <a:picLocks noChangeAspect="1"/>
+          </p:cNvPicPr>
           <p:nvPr/>
-        </p:nvSpPr>
+        </p:nvPicPr>
+        <p:blipFill>
+          <a:blip r:embed="rId2"/>
+          <a:stretch>
+            <a:fillRect/>
+          </a:stretch>
+        </p:blipFill>
         <p:spPr>
           <a:xfrm>
-            <a:off x="731520" y="1371600"/>
-            <a:ext cx="6400800" cy="3200400"/>
+            <a:off x="457200" y="1188720"/>
+            <a:ext cx="5943600" cy="3200400"/>
           </a:xfrm>
           <a:prstGeom prst="rect">
             <a:avLst/>
           </a:prstGeom>
-          <a:noFill/>
         </p:spPr>
-        <p:txBody>
-          <a:bodyPr wrap="square">
-            <a:spAutoFit/>
-          </a:bodyPr>
-          <a:lstStyle/>
-          <a:p>
-            <a:pPr algn="l">
-              <a:defRPr sz="1400" b="0">
-                <a:solidFill>
-                  <a:srgbClr val="1C2A3A"/>
-                </a:solidFill>
-                <a:latin typeface="Consolas"/>
-              </a:defRPr>
-            </a:pPr>
-            <a:r>
-              <a:t>Domain-Specific Dataset (e.g., 8,000+ financial Q&amp;A pairs)</a:t>
-            </a:r>
-            <a:br/>
-            <a:r>
-              <a:t>     |</a:t>
-            </a:r>
-            <a:br/>
-            <a:r>
-              <a:t>  [1. PREPARE]     Format data as instruction/response pairs</a:t>
-            </a:r>
-            <a:br/>
-            <a:r>
-              <a:t>     |</a:t>
-            </a:r>
-            <a:br/>
-            <a:r>
-              <a:t>  [2. TRAIN]       Update model weights (Full / LoRA / QLoRA)</a:t>
-            </a:r>
-            <a:br/>
-            <a:r>
-              <a:t>     |</a:t>
-            </a:r>
-            <a:br/>
-            <a:r>
-              <a:t>  [3. EVALUATE]    Test on held-out data, measure accuracy</a:t>
-            </a:r>
-            <a:br/>
-            <a:r>
-              <a:t>     |</a:t>
-            </a:r>
-            <a:br/>
-            <a:r>
-              <a:t>  [4. DEPLOY]      Use the specialized model for inference</a:t>
-            </a:r>
-            <a:br/>
-            <a:r>
-              <a:t>     |</a:t>
-            </a:r>
-            <a:br/>
-            <a:r>
-              <a:t>  Model with NEW capabilities</a:t>
-            </a:r>
-          </a:p>
-        </p:txBody>
-      </p:sp>
+      </p:pic>
       <p:sp>
         <p:nvSpPr>
           <p:cNvPr id="4" name="Rectangle 3"/>

</xml_diff>